<commit_message>
pushed wireless and switching incompleted notes
</commit_message>
<xml_diff>
--- a/Security.pptx
+++ b/Security.pptx
@@ -267,7 +267,7 @@
           <a:p>
             <a:fld id="{7543CEF8-A599-4ECC-AF2C-F60928719C31}" type="datetimeFigureOut">
               <a:rPr lang="en-IN" smtClean="0"/>
-              <a:t>31-08-2025</a:t>
+              <a:t>14-09-2025</a:t>
             </a:fld>
             <a:endParaRPr lang="en-IN"/>
           </a:p>
@@ -437,7 +437,7 @@
           <a:p>
             <a:fld id="{7543CEF8-A599-4ECC-AF2C-F60928719C31}" type="datetimeFigureOut">
               <a:rPr lang="en-IN" smtClean="0"/>
-              <a:t>31-08-2025</a:t>
+              <a:t>14-09-2025</a:t>
             </a:fld>
             <a:endParaRPr lang="en-IN"/>
           </a:p>
@@ -617,7 +617,7 @@
           <a:p>
             <a:fld id="{7543CEF8-A599-4ECC-AF2C-F60928719C31}" type="datetimeFigureOut">
               <a:rPr lang="en-IN" smtClean="0"/>
-              <a:t>31-08-2025</a:t>
+              <a:t>14-09-2025</a:t>
             </a:fld>
             <a:endParaRPr lang="en-IN"/>
           </a:p>
@@ -787,7 +787,7 @@
           <a:p>
             <a:fld id="{7543CEF8-A599-4ECC-AF2C-F60928719C31}" type="datetimeFigureOut">
               <a:rPr lang="en-IN" smtClean="0"/>
-              <a:t>31-08-2025</a:t>
+              <a:t>14-09-2025</a:t>
             </a:fld>
             <a:endParaRPr lang="en-IN"/>
           </a:p>
@@ -1031,7 +1031,7 @@
           <a:p>
             <a:fld id="{7543CEF8-A599-4ECC-AF2C-F60928719C31}" type="datetimeFigureOut">
               <a:rPr lang="en-IN" smtClean="0"/>
-              <a:t>31-08-2025</a:t>
+              <a:t>14-09-2025</a:t>
             </a:fld>
             <a:endParaRPr lang="en-IN"/>
           </a:p>
@@ -1263,7 +1263,7 @@
           <a:p>
             <a:fld id="{7543CEF8-A599-4ECC-AF2C-F60928719C31}" type="datetimeFigureOut">
               <a:rPr lang="en-IN" smtClean="0"/>
-              <a:t>31-08-2025</a:t>
+              <a:t>14-09-2025</a:t>
             </a:fld>
             <a:endParaRPr lang="en-IN"/>
           </a:p>
@@ -1630,7 +1630,7 @@
           <a:p>
             <a:fld id="{7543CEF8-A599-4ECC-AF2C-F60928719C31}" type="datetimeFigureOut">
               <a:rPr lang="en-IN" smtClean="0"/>
-              <a:t>31-08-2025</a:t>
+              <a:t>14-09-2025</a:t>
             </a:fld>
             <a:endParaRPr lang="en-IN"/>
           </a:p>
@@ -1748,7 +1748,7 @@
           <a:p>
             <a:fld id="{7543CEF8-A599-4ECC-AF2C-F60928719C31}" type="datetimeFigureOut">
               <a:rPr lang="en-IN" smtClean="0"/>
-              <a:t>31-08-2025</a:t>
+              <a:t>14-09-2025</a:t>
             </a:fld>
             <a:endParaRPr lang="en-IN"/>
           </a:p>
@@ -1843,7 +1843,7 @@
           <a:p>
             <a:fld id="{7543CEF8-A599-4ECC-AF2C-F60928719C31}" type="datetimeFigureOut">
               <a:rPr lang="en-IN" smtClean="0"/>
-              <a:t>31-08-2025</a:t>
+              <a:t>14-09-2025</a:t>
             </a:fld>
             <a:endParaRPr lang="en-IN"/>
           </a:p>
@@ -2120,7 +2120,7 @@
           <a:p>
             <a:fld id="{7543CEF8-A599-4ECC-AF2C-F60928719C31}" type="datetimeFigureOut">
               <a:rPr lang="en-IN" smtClean="0"/>
-              <a:t>31-08-2025</a:t>
+              <a:t>14-09-2025</a:t>
             </a:fld>
             <a:endParaRPr lang="en-IN"/>
           </a:p>
@@ -2377,7 +2377,7 @@
           <a:p>
             <a:fld id="{7543CEF8-A599-4ECC-AF2C-F60928719C31}" type="datetimeFigureOut">
               <a:rPr lang="en-IN" smtClean="0"/>
-              <a:t>31-08-2025</a:t>
+              <a:t>14-09-2025</a:t>
             </a:fld>
             <a:endParaRPr lang="en-IN"/>
           </a:p>
@@ -2590,7 +2590,7 @@
           <a:p>
             <a:fld id="{7543CEF8-A599-4ECC-AF2C-F60928719C31}" type="datetimeFigureOut">
               <a:rPr lang="en-IN" smtClean="0"/>
-              <a:t>31-08-2025</a:t>
+              <a:t>14-09-2025</a:t>
             </a:fld>
             <a:endParaRPr lang="en-IN"/>
           </a:p>
@@ -4259,21 +4259,13 @@
           </a:bodyPr>
           <a:lstStyle/>
           <a:p>
-            <a:pPr algn="l"/>
-            <a:br>
+            <a:r>
               <a:rPr lang="en-US" sz="4000" b="1" dirty="0">
                 <a:solidFill>
                   <a:schemeClr val="bg1"/>
                 </a:solidFill>
               </a:rPr>
-            </a:br>
-            <a:r>
-              <a:rPr lang="en-US" sz="4000" b="1" dirty="0">
-                <a:solidFill>
-                  <a:schemeClr val="bg1"/>
-                </a:solidFill>
-              </a:rPr>
-              <a:t>			        Trojans</a:t>
+              <a:t>Malware Distribution</a:t>
             </a:r>
             <a:endParaRPr lang="en-IN" sz="4000" b="1" dirty="0">
               <a:solidFill>
@@ -4815,21 +4807,13 @@
           </a:bodyPr>
           <a:lstStyle/>
           <a:p>
-            <a:pPr algn="l"/>
-            <a:br>
+            <a:r>
               <a:rPr lang="en-US" sz="4000" b="1" dirty="0">
                 <a:solidFill>
                   <a:schemeClr val="bg1"/>
                 </a:solidFill>
               </a:rPr>
-            </a:br>
-            <a:r>
-              <a:rPr lang="en-US" sz="4000" b="1" dirty="0">
-                <a:solidFill>
-                  <a:schemeClr val="bg1"/>
-                </a:solidFill>
-              </a:rPr>
-              <a:t>			        Trojans</a:t>
+              <a:t>short notes on threats</a:t>
             </a:r>
             <a:endParaRPr lang="en-IN" sz="4000" b="1" dirty="0">
               <a:solidFill>

</xml_diff>